<commit_message>
Add GitHub repo link to final slide of presentation
</commit_message>
<xml_diff>
--- a/NBA_Analytics_Presentation_FULL.pptx
+++ b/NBA_Analytics_Presentation_FULL.pptx
@@ -1365,7 +1365,7 @@
         <a:lstStyle/>
         <a:p>
           <a:pPr>
-            <a:defRPr sz="1000">      </a:defRPr>
+            <a:defRPr sz="1000"/>
           </a:pPr>
           <a:endParaRPr lang="en-US"/>
         </a:p>
@@ -1812,7 +1812,7 @@
         <a:lstStyle/>
         <a:p>
           <a:pPr>
-            <a:defRPr sz="900">      </a:defRPr>
+            <a:defRPr sz="900"/>
           </a:pPr>
           <a:endParaRPr lang="en-US"/>
         </a:p>
@@ -28049,6 +28049,41 @@
           </a:ln>
         </p:spPr>
       </p:sp>
+      <p:sp>
+        <p:nvSpPr>
+          <p:cNvPr id="19" name="GitHub Link"/>
+          <p:cNvSpPr/>
+          <p:nvPr/>
+        </p:nvSpPr>
+        <p:spPr>
+          <a:xfrm>
+            <a:off x="0" y="5001768"/>
+            <a:ext cx="9144000" cy="141732"/>
+          </a:xfrm>
+          <a:prstGeom prst="rect">
+            <a:avLst/>
+          </a:prstGeom>
+          <a:noFill/>
+          <a:ln/>
+        </p:spPr>
+        <p:txBody>
+          <a:bodyPr wrap="square" lIns="91440" tIns="0" rIns="91440" bIns="0" rtlCol="0" anchor="ctr"/>
+          <a:lstStyle/>
+          <a:p>
+            <a:pPr algn="ctr" indent="0" marL="0">
+              <a:buNone/>
+            </a:pPr>
+            <a:r>
+              <a:rPr lang="en-US" sz="800" b="1" dirty="0">
+                <a:solidFill>
+                  <a:srgbClr val="FFFFFF"/>
+                </a:solidFill>
+              </a:rPr>
+              <a:t>github.com/SlavaVyunik/nba-analytics-dashboard</a:t>
+            </a:r>
+          </a:p>
+        </p:txBody>
+      </p:sp>
     </p:spTree>
   </p:cSld>
   <p:clrMapOvr>

</xml_diff>

<commit_message>
Add Streamlit app URL to final slide
</commit_message>
<xml_diff>
--- a/NBA_Analytics_Presentation_FULL.pptx
+++ b/NBA_Analytics_Presentation_FULL.pptx
@@ -28074,12 +28074,28 @@
               <a:buNone/>
             </a:pPr>
             <a:r>
-              <a:rPr lang="en-US" sz="800" b="1" dirty="0">
+              <a:rPr lang="en-US" sz="750" b="1" dirty="0">
                 <a:solidFill>
                   <a:srgbClr val="FFFFFF"/>
                 </a:solidFill>
               </a:rPr>
               <a:t>github.com/SlavaVyunik/nba-analytics-dashboard</a:t>
+            </a:r>
+            <a:r>
+              <a:rPr lang="en-US" sz="750" dirty="0">
+                <a:solidFill>
+                  <a:srgbClr val="FFB3B3"/>
+                </a:solidFill>
+              </a:rPr>
+              <a:t>   ·   </a:t>
+            </a:r>
+            <a:r>
+              <a:rPr lang="en-US" sz="750" b="1" dirty="0">
+                <a:solidFill>
+                  <a:srgbClr val="FFFFFF"/>
+                </a:solidFill>
+              </a:rPr>
+              <a:t>nba-analytics-dashboard-ancv7lxitqgb5zxgdjhqgm.streamlit.app</a:t>
             </a:r>
           </a:p>
         </p:txBody>

</xml_diff>

<commit_message>
Add GitHub and Streamlit links to title slide (slide 1)
</commit_message>
<xml_diff>
--- a/NBA_Analytics_Presentation_FULL.pptx
+++ b/NBA_Analytics_Presentation_FULL.pptx
@@ -5779,6 +5779,108 @@
             <a:prstDash val="solid"/>
           </a:ln>
         </p:spPr>
+      </p:sp>
+      <p:sp>
+        <p:nvSpPr>
+          <p:cNvPr id="20" name="GitHub Box"/>
+          <p:cNvSpPr/>
+          <p:nvPr/>
+        </p:nvSpPr>
+        <p:spPr>
+          <a:xfrm>
+            <a:off x="502920" y="4530000"/>
+            <a:ext cx="3840000" cy="274320"/>
+          </a:xfrm>
+          <a:prstGeom prst="roundRect">
+            <a:avLst>
+              <a:gd name="adj" fmla="val 20000"/>
+            </a:avLst>
+          </a:prstGeom>
+          <a:solidFill>
+            <a:srgbClr val="0d1825"/>
+          </a:solidFill>
+          <a:ln w="19050">
+            <a:solidFill>
+              <a:srgbClr val="C8102E"/>
+            </a:solidFill>
+          </a:ln>
+        </p:spPr>
+        <p:txBody>
+          <a:bodyPr wrap="square" lIns="91440" tIns="0" rIns="91440" bIns="0" rtlCol="0" anchor="ctr"/>
+          <a:lstStyle/>
+          <a:p>
+            <a:pPr algn="ctr" indent="0" marL="0">
+              <a:buNone/>
+            </a:pPr>
+            <a:r>
+              <a:rPr lang="en-US" sz="900" dirty="0">
+                <a:solidFill>
+                  <a:srgbClr val="94A3B8"/>
+                </a:solidFill>
+              </a:rPr>
+              <a:t>🔗 GitHub: </a:t>
+            </a:r>
+            <a:r>
+              <a:rPr lang="en-US" sz="900" b="1" dirty="0">
+                <a:solidFill>
+                  <a:srgbClr val="FFFFFF"/>
+                </a:solidFill>
+              </a:rPr>
+              <a:t>github.com/SlavaVyunik/nba-analytics-dashboard</a:t>
+            </a:r>
+          </a:p>
+        </p:txBody>
+      </p:sp>
+      <p:sp>
+        <p:nvSpPr>
+          <p:cNvPr id="21" name="Streamlit Box"/>
+          <p:cNvSpPr/>
+          <p:nvPr/>
+        </p:nvSpPr>
+        <p:spPr>
+          <a:xfrm>
+            <a:off x="4434960" y="4530000"/>
+            <a:ext cx="3840000" cy="274320"/>
+          </a:xfrm>
+          <a:prstGeom prst="roundRect">
+            <a:avLst>
+              <a:gd name="adj" fmla="val 20000"/>
+            </a:avLst>
+          </a:prstGeom>
+          <a:solidFill>
+            <a:srgbClr val="0d1825"/>
+          </a:solidFill>
+          <a:ln w="19050">
+            <a:solidFill>
+              <a:srgbClr val="1D428A"/>
+            </a:solidFill>
+          </a:ln>
+        </p:spPr>
+        <p:txBody>
+          <a:bodyPr wrap="square" lIns="91440" tIns="0" rIns="91440" bIns="0" rtlCol="0" anchor="ctr"/>
+          <a:lstStyle/>
+          <a:p>
+            <a:pPr algn="ctr" indent="0" marL="0">
+              <a:buNone/>
+            </a:pPr>
+            <a:r>
+              <a:rPr lang="en-US" sz="900" dirty="0">
+                <a:solidFill>
+                  <a:srgbClr val="94A3B8"/>
+                </a:solidFill>
+              </a:rPr>
+              <a:t>🌐 Demo: </a:t>
+            </a:r>
+            <a:r>
+              <a:rPr lang="en-US" sz="900" b="1" dirty="0">
+                <a:solidFill>
+                  <a:srgbClr val="58A6FF"/>
+                </a:solidFill>
+              </a:rPr>
+              <a:t>nba-analytics-dashboard-ancv7lxitqgb5zxgdjhqgm.streamlit.app</a:t>
+            </a:r>
+          </a:p>
+        </p:txBody>
       </p:sp>
     </p:spTree>
   </p:cSld>
@@ -28079,23 +28181,7 @@
                   <a:srgbClr val="FFFFFF"/>
                 </a:solidFill>
               </a:rPr>
-              <a:t>github.com/SlavaVyunik/nba-analytics-dashboard</a:t>
-            </a:r>
-            <a:r>
-              <a:rPr lang="en-US" sz="750" dirty="0">
-                <a:solidFill>
-                  <a:srgbClr val="FFB3B3"/>
-                </a:solidFill>
-              </a:rPr>
-              <a:t>   ·   </a:t>
-            </a:r>
-            <a:r>
-              <a:rPr lang="en-US" sz="750" b="1" dirty="0">
-                <a:solidFill>
-                  <a:srgbClr val="FFFFFF"/>
-                </a:solidFill>
-              </a:rPr>
-              <a:t>nba-analytics-dashboard-ancv7lxitqgb5zxgdjhqgm.streamlit.app</a:t>
+              <a:t>🔗 github.com/SlavaVyunik/nba-analytics-dashboard   ·   🌐 nba-analytics-dashboard-ancv7lxitqgb5zxgdjhqgm.streamlit.app</a:t>
             </a:r>
           </a:p>
         </p:txBody>

</xml_diff>

<commit_message>
Make GitHub and Streamlit links clickable on title slide
</commit_message>
<xml_diff>
--- a/NBA_Analytics_Presentation_FULL.pptx
+++ b/NBA_Analytics_Presentation_FULL.pptx
@@ -5813,20 +5813,13 @@
               <a:buNone/>
             </a:pPr>
             <a:r>
-              <a:rPr lang="en-US" sz="900" dirty="0">
-                <a:solidFill>
-                  <a:srgbClr val="94A3B8"/>
-                </a:solidFill>
-              </a:rPr>
-              <a:t>🔗 GitHub: </a:t>
-            </a:r>
-            <a:r>
               <a:rPr lang="en-US" sz="900" b="1" dirty="0">
                 <a:solidFill>
                   <a:srgbClr val="FFFFFF"/>
                 </a:solidFill>
-              </a:rPr>
-              <a:t>github.com/SlavaVyunik/nba-analytics-dashboard</a:t>
+                <a:hlinkClick r:id="rId3"/>
+              </a:rPr>
+              <a:t>🔗 GitHub: github.com/SlavaVyunik/nba-analytics-dashboard</a:t>
             </a:r>
           </a:p>
         </p:txBody>
@@ -5864,20 +5857,13 @@
               <a:buNone/>
             </a:pPr>
             <a:r>
-              <a:rPr lang="en-US" sz="900" dirty="0">
-                <a:solidFill>
-                  <a:srgbClr val="94A3B8"/>
-                </a:solidFill>
-              </a:rPr>
-              <a:t>🌐 Demo: </a:t>
-            </a:r>
-            <a:r>
               <a:rPr lang="en-US" sz="900" b="1" dirty="0">
                 <a:solidFill>
                   <a:srgbClr val="58A6FF"/>
                 </a:solidFill>
-              </a:rPr>
-              <a:t>nba-analytics-dashboard-ancv7lxitqgb5zxgdjhqgm.streamlit.app</a:t>
+                <a:hlinkClick r:id="rId4"/>
+              </a:rPr>
+              <a:t>🌐 Demo: nba-analytics-dashboard-ancv7lxitqgb5zxgdjhqgm.streamlit.app</a:t>
             </a:r>
           </a:p>
         </p:txBody>

</xml_diff>